<commit_message>
chore(privacidad): proteger a las personas entrevistadas y fijar responsables de revisión
- Mueve a .investigacion_privada/ (ignorado por git) el video, el audio y los
  11 PDF de campo y de UX, que contenían nombres, fotos y números de control.
- Sustituye nombres de entrevistadas por rol y comunidad en docs, app,
  generadores de presentaciones y los .pptx; la bordadora de Tijaltepec, que
  pidió no ser identificada, queda sin nombre ni edad.
- Renombra archivos y carpetas que llevaban nombres de personas.
- Quita los números de control de estudiantes y los enlaces a adjuntos de GitHub.
- El reproductor de video se sustituye por un aviso; sin botón de descarga.
- Agrega docs/research/PRIVACIDAD.md, reglas en .gitignore y un job de CI
  que rechaza PR con audio, video, imágenes o PDF en carpetas de investigación.
- Agrega .github/CODEOWNERS y las reglas de privacidad y revisión a CONTRIBUTING.

Co-Authored-By: Claude Opus 5.5 <noreply@anthropic.com>
</commit_message>
<xml_diff>
--- a/Raiz_Protocol_Dossier_Econometrico_Mixteca.pptx
+++ b/Raiz_Protocol_Dossier_Econometrico_Mixteca.pptx
@@ -2565,7 +2565,7 @@
                 <a:ea typeface="Calibri" pitchFamily="34" charset="-122"/>
                 <a:cs typeface="Calibri" pitchFamily="34" charset="-120"/>
               </a:rPr>
-              <a:t>• San Antonio Nduaxico: Invernaderos de tomate saladette (Josué Gerardo Sanjuan) - Vulnerabilidad extrema a 5 días de anaquel.</a:t>
+              <a:t>• San Antonio Nduaxico: Invernaderos de tomate saladette (productor local) - Vulnerabilidad extrema a 5 días de anaquel.</a:t>
             </a:r>
             <a:endParaRPr lang="en-US" sz="1100" dirty="0"/>
           </a:p>
@@ -2623,7 +2623,7 @@
                 <a:ea typeface="Calibri" pitchFamily="34" charset="-122"/>
                 <a:cs typeface="Calibri" pitchFamily="34" charset="-120"/>
               </a:rPr>
-              <a:t>• San Pablo Tijaltepec: Bordado fino de pepenado (Doña Francisca, 64 años) - 6 a 9 meses de confección desvalorizados por maquila.</a:t>
+              <a:t>• San Pablo Tijaltepec: Bordado fino de pepenado (bordadora de la comunidad) - 6 a 9 meses de confección desvalorizados por maquila.</a:t>
             </a:r>
             <a:endParaRPr lang="en-US" sz="1100" dirty="0"/>
           </a:p>
@@ -2652,7 +2652,7 @@
                 <a:ea typeface="Calibri" pitchFamily="34" charset="-122"/>
                 <a:cs typeface="Calibri" pitchFamily="34" charset="-120"/>
               </a:rPr>
-              <a:t>• San José Xochixtlán: Telar de cintura triqui (Doña Reyna, 56 años) - Descuentos arbitrarios impuestos a la entrega física.</a:t>
+              <a:t>• San José Xochixtlán: Telar de cintura triqui (tejedora de 56 años) - Descuentos arbitrarios impuestos a la entrega física.</a:t>
             </a:r>
             <a:endParaRPr lang="en-US" sz="1100" dirty="0"/>
           </a:p>
@@ -2681,7 +2681,7 @@
                 <a:ea typeface="Calibri" pitchFamily="34" charset="-122"/>
                 <a:cs typeface="Calibri" pitchFamily="34" charset="-120"/>
               </a:rPr>
-              <a:t>• Heroica Ciudad de Tlaxiaco: Fibras vegetales &amp; panadería artesanal de horno de leña (Guadalupe Avendaño).</a:t>
+              <a:t>• Heroica Ciudad de Tlaxiaco: Fibras vegetales &amp; panadería artesanal de horno de leña (panadera de la comunidad).</a:t>
             </a:r>
             <a:endParaRPr lang="en-US" sz="1100" dirty="0"/>
           </a:p>
@@ -6002,7 +6002,7 @@
                 <a:ea typeface="Calibri" pitchFamily="34" charset="-122"/>
                 <a:cs typeface="Calibri" pitchFamily="34" charset="-120"/>
               </a:rPr>
-              <a:t>El Contraejemplo: Doña Mercedes Cruz (Chocolate Artesanal)</a:t>
+              <a:t>El Contraejemplo: Productora de Chocolate Artesanal</a:t>
             </a:r>
             <a:endParaRPr lang="en-US" sz="2000" dirty="0"/>
           </a:p>
@@ -6275,7 +6275,7 @@
                 <a:ea typeface="Calibri" pitchFamily="34" charset="-122"/>
                 <a:cs typeface="Calibri" pitchFamily="34" charset="-120"/>
               </a:rPr>
-              <a:t>Doña Mercedes Cruz</a:t>
+              <a:t>Productora de chocolate, Oaxaca</a:t>
             </a:r>
             <a:endParaRPr lang="en-US" sz="1500" dirty="0"/>
           </a:p>
@@ -6599,7 +6599,7 @@
                 <a:ea typeface="Calibri" pitchFamily="34" charset="-122"/>
                 <a:cs typeface="Calibri" pitchFamily="34" charset="-120"/>
               </a:rPr>
-              <a:t>Mercedes Cruz demostró que un productor con canal directo y reputación verificable no puede ser extorsionado por acopiadores.</a:t>
+              <a:t>Esta productora demostró que un productor con canal directo y reputación verificable no puede ser extorsionado por acopiadores.</a:t>
             </a:r>
             <a:endParaRPr lang="en-US" sz="1100" dirty="0"/>
           </a:p>

</xml_diff>